<commit_message>
ECCE 2025 and Access Paper
</commit_message>
<xml_diff>
--- a/ECCE-2025/ExperimentalResult.pptx
+++ b/ECCE-2025/ExperimentalResult.pptx
@@ -6,7 +6,8 @@
   </p:sldMasterIdLst>
   <p:sldIdLst>
     <p:sldId id="256" r:id="rId2"/>
-    <p:sldId id="257" r:id="rId3"/>
+    <p:sldId id="258" r:id="rId3"/>
+    <p:sldId id="257" r:id="rId4"/>
   </p:sldIdLst>
   <p:sldSz cx="12192000" cy="6858000"/>
   <p:notesSz cx="6858000" cy="9144000"/>
@@ -244,7 +245,7 @@
           <a:p>
             <a:fld id="{2345BACE-A86F-424A-B76D-4397202C805E}" type="datetimeFigureOut">
               <a:rPr lang="sv-SE" smtClean="0"/>
-              <a:t>2025-02-13</a:t>
+              <a:t>2025-02-20</a:t>
             </a:fld>
             <a:endParaRPr lang="sv-SE"/>
           </a:p>
@@ -414,7 +415,7 @@
           <a:p>
             <a:fld id="{2345BACE-A86F-424A-B76D-4397202C805E}" type="datetimeFigureOut">
               <a:rPr lang="sv-SE" smtClean="0"/>
-              <a:t>2025-02-13</a:t>
+              <a:t>2025-02-20</a:t>
             </a:fld>
             <a:endParaRPr lang="sv-SE"/>
           </a:p>
@@ -594,7 +595,7 @@
           <a:p>
             <a:fld id="{2345BACE-A86F-424A-B76D-4397202C805E}" type="datetimeFigureOut">
               <a:rPr lang="sv-SE" smtClean="0"/>
-              <a:t>2025-02-13</a:t>
+              <a:t>2025-02-20</a:t>
             </a:fld>
             <a:endParaRPr lang="sv-SE"/>
           </a:p>
@@ -764,7 +765,7 @@
           <a:p>
             <a:fld id="{2345BACE-A86F-424A-B76D-4397202C805E}" type="datetimeFigureOut">
               <a:rPr lang="sv-SE" smtClean="0"/>
-              <a:t>2025-02-13</a:t>
+              <a:t>2025-02-20</a:t>
             </a:fld>
             <a:endParaRPr lang="sv-SE"/>
           </a:p>
@@ -1010,7 +1011,7 @@
           <a:p>
             <a:fld id="{2345BACE-A86F-424A-B76D-4397202C805E}" type="datetimeFigureOut">
               <a:rPr lang="sv-SE" smtClean="0"/>
-              <a:t>2025-02-13</a:t>
+              <a:t>2025-02-20</a:t>
             </a:fld>
             <a:endParaRPr lang="sv-SE"/>
           </a:p>
@@ -1242,7 +1243,7 @@
           <a:p>
             <a:fld id="{2345BACE-A86F-424A-B76D-4397202C805E}" type="datetimeFigureOut">
               <a:rPr lang="sv-SE" smtClean="0"/>
-              <a:t>2025-02-13</a:t>
+              <a:t>2025-02-20</a:t>
             </a:fld>
             <a:endParaRPr lang="sv-SE"/>
           </a:p>
@@ -1609,7 +1610,7 @@
           <a:p>
             <a:fld id="{2345BACE-A86F-424A-B76D-4397202C805E}" type="datetimeFigureOut">
               <a:rPr lang="sv-SE" smtClean="0"/>
-              <a:t>2025-02-13</a:t>
+              <a:t>2025-02-20</a:t>
             </a:fld>
             <a:endParaRPr lang="sv-SE"/>
           </a:p>
@@ -1727,7 +1728,7 @@
           <a:p>
             <a:fld id="{2345BACE-A86F-424A-B76D-4397202C805E}" type="datetimeFigureOut">
               <a:rPr lang="sv-SE" smtClean="0"/>
-              <a:t>2025-02-13</a:t>
+              <a:t>2025-02-20</a:t>
             </a:fld>
             <a:endParaRPr lang="sv-SE"/>
           </a:p>
@@ -1822,7 +1823,7 @@
           <a:p>
             <a:fld id="{2345BACE-A86F-424A-B76D-4397202C805E}" type="datetimeFigureOut">
               <a:rPr lang="sv-SE" smtClean="0"/>
-              <a:t>2025-02-13</a:t>
+              <a:t>2025-02-20</a:t>
             </a:fld>
             <a:endParaRPr lang="sv-SE"/>
           </a:p>
@@ -2099,7 +2100,7 @@
           <a:p>
             <a:fld id="{2345BACE-A86F-424A-B76D-4397202C805E}" type="datetimeFigureOut">
               <a:rPr lang="sv-SE" smtClean="0"/>
-              <a:t>2025-02-13</a:t>
+              <a:t>2025-02-20</a:t>
             </a:fld>
             <a:endParaRPr lang="sv-SE"/>
           </a:p>
@@ -2352,7 +2353,7 @@
           <a:p>
             <a:fld id="{2345BACE-A86F-424A-B76D-4397202C805E}" type="datetimeFigureOut">
               <a:rPr lang="sv-SE" smtClean="0"/>
-              <a:t>2025-02-13</a:t>
+              <a:t>2025-02-20</a:t>
             </a:fld>
             <a:endParaRPr lang="sv-SE"/>
           </a:p>
@@ -2565,7 +2566,7 @@
           <a:p>
             <a:fld id="{2345BACE-A86F-424A-B76D-4397202C805E}" type="datetimeFigureOut">
               <a:rPr lang="sv-SE" smtClean="0"/>
-              <a:t>2025-02-13</a:t>
+              <a:t>2025-02-20</a:t>
             </a:fld>
             <a:endParaRPr lang="sv-SE"/>
           </a:p>
@@ -3064,6 +3065,911 @@
               </a:ext>
             </a:extLst>
           </a:blip>
+          <a:srcRect l="6107" t="36172" r="4602" b="13247"/>
+          <a:stretch/>
+        </p:blipFill>
+        <p:spPr>
+          <a:xfrm>
+            <a:off x="2108199" y="1704974"/>
+            <a:ext cx="6591301" cy="2800351"/>
+          </a:xfrm>
+          <a:prstGeom prst="rect">
+            <a:avLst/>
+          </a:prstGeom>
+        </p:spPr>
+      </p:pic>
+      <p:cxnSp>
+        <p:nvCxnSpPr>
+          <p:cNvPr id="6" name="Straight Arrow Connector 5"/>
+          <p:cNvCxnSpPr>
+            <a:endCxn id="24" idx="2"/>
+          </p:cNvCxnSpPr>
+          <p:nvPr/>
+        </p:nvCxnSpPr>
+        <p:spPr>
+          <a:xfrm flipH="1" flipV="1">
+            <a:off x="3779898" y="2317750"/>
+            <a:ext cx="7246" cy="1079822"/>
+          </a:xfrm>
+          <a:prstGeom prst="straightConnector1">
+            <a:avLst/>
+          </a:prstGeom>
+          <a:ln w="12700">
+            <a:solidFill>
+              <a:srgbClr val="FF0000"/>
+            </a:solidFill>
+            <a:tailEnd type="triangle"/>
+          </a:ln>
+          <a:effectLst>
+            <a:glow rad="25400">
+              <a:schemeClr val="bg1"/>
+            </a:glow>
+            <a:outerShdw blurRad="50800" dist="38100" dir="2700000" algn="tl" rotWithShape="0">
+              <a:schemeClr val="bg1">
+                <a:alpha val="0"/>
+              </a:schemeClr>
+            </a:outerShdw>
+            <a:reflection blurRad="6350" stA="0" endPos="35000" dir="5400000" sy="-100000" algn="bl" rotWithShape="0"/>
+          </a:effectLst>
+        </p:spPr>
+        <p:style>
+          <a:lnRef idx="1">
+            <a:schemeClr val="accent1"/>
+          </a:lnRef>
+          <a:fillRef idx="0">
+            <a:schemeClr val="accent1"/>
+          </a:fillRef>
+          <a:effectRef idx="0">
+            <a:schemeClr val="accent1"/>
+          </a:effectRef>
+          <a:fontRef idx="minor">
+            <a:schemeClr val="tx1"/>
+          </a:fontRef>
+        </p:style>
+      </p:cxnSp>
+      <p:sp>
+        <p:nvSpPr>
+          <p:cNvPr id="14" name="Rectangle 13"/>
+          <p:cNvSpPr/>
+          <p:nvPr/>
+        </p:nvSpPr>
+        <p:spPr>
+          <a:xfrm>
+            <a:off x="4809211" y="2686210"/>
+            <a:ext cx="708186" cy="355761"/>
+          </a:xfrm>
+          <a:prstGeom prst="rect">
+            <a:avLst/>
+          </a:prstGeom>
+          <a:solidFill>
+            <a:schemeClr val="bg1"/>
+          </a:solidFill>
+          <a:ln>
+            <a:solidFill>
+              <a:srgbClr val="FF0000"/>
+            </a:solidFill>
+          </a:ln>
+          <a:effectLst>
+            <a:glow rad="25400">
+              <a:schemeClr val="bg1">
+                <a:alpha val="40000"/>
+              </a:schemeClr>
+            </a:glow>
+          </a:effectLst>
+        </p:spPr>
+        <p:style>
+          <a:lnRef idx="2">
+            <a:schemeClr val="accent1">
+              <a:shade val="50000"/>
+            </a:schemeClr>
+          </a:lnRef>
+          <a:fillRef idx="1">
+            <a:schemeClr val="accent1"/>
+          </a:fillRef>
+          <a:effectRef idx="0">
+            <a:schemeClr val="accent1"/>
+          </a:effectRef>
+          <a:fontRef idx="minor">
+            <a:schemeClr val="lt1"/>
+          </a:fontRef>
+        </p:style>
+        <p:txBody>
+          <a:bodyPr rtlCol="0" anchor="ctr"/>
+          <a:lstStyle/>
+          <a:p>
+            <a:pPr algn="ctr"/>
+            <a:r>
+              <a:rPr lang="sv-SE" sz="1200" b="1" dirty="0" err="1" smtClean="0">
+                <a:solidFill>
+                  <a:schemeClr val="tx1"/>
+                </a:solidFill>
+                <a:latin typeface="Times New Roman" panose="02020603050405020304" pitchFamily="18" charset="0"/>
+                <a:cs typeface="Times New Roman" panose="02020603050405020304" pitchFamily="18" charset="0"/>
+              </a:rPr>
+              <a:t>Voltage</a:t>
+            </a:r>
+            <a:r>
+              <a:rPr lang="sv-SE" sz="1200" b="1" dirty="0" smtClean="0">
+                <a:solidFill>
+                  <a:schemeClr val="tx1"/>
+                </a:solidFill>
+                <a:latin typeface="Times New Roman" panose="02020603050405020304" pitchFamily="18" charset="0"/>
+                <a:cs typeface="Times New Roman" panose="02020603050405020304" pitchFamily="18" charset="0"/>
+              </a:rPr>
+              <a:t> </a:t>
+            </a:r>
+            <a:r>
+              <a:rPr lang="sv-SE" sz="1200" b="1" dirty="0" err="1" smtClean="0">
+                <a:solidFill>
+                  <a:schemeClr val="tx1"/>
+                </a:solidFill>
+                <a:latin typeface="Times New Roman" panose="02020603050405020304" pitchFamily="18" charset="0"/>
+                <a:cs typeface="Times New Roman" panose="02020603050405020304" pitchFamily="18" charset="0"/>
+              </a:rPr>
+              <a:t>Probes</a:t>
+            </a:r>
+            <a:endParaRPr lang="sv-SE" sz="1200" b="1" dirty="0">
+              <a:solidFill>
+                <a:schemeClr val="tx1"/>
+              </a:solidFill>
+              <a:latin typeface="Times New Roman" panose="02020603050405020304" pitchFamily="18" charset="0"/>
+              <a:cs typeface="Times New Roman" panose="02020603050405020304" pitchFamily="18" charset="0"/>
+            </a:endParaRPr>
+          </a:p>
+        </p:txBody>
+      </p:sp>
+      <p:cxnSp>
+        <p:nvCxnSpPr>
+          <p:cNvPr id="15" name="Straight Arrow Connector 14"/>
+          <p:cNvCxnSpPr/>
+          <p:nvPr/>
+        </p:nvCxnSpPr>
+        <p:spPr>
+          <a:xfrm flipH="1" flipV="1">
+            <a:off x="2806700" y="2311400"/>
+            <a:ext cx="27943" cy="616272"/>
+          </a:xfrm>
+          <a:prstGeom prst="straightConnector1">
+            <a:avLst/>
+          </a:prstGeom>
+          <a:ln w="12700">
+            <a:solidFill>
+              <a:srgbClr val="FF0000"/>
+            </a:solidFill>
+            <a:tailEnd type="triangle"/>
+          </a:ln>
+          <a:effectLst>
+            <a:glow rad="25400">
+              <a:schemeClr val="bg1"/>
+            </a:glow>
+            <a:outerShdw blurRad="50800" dist="38100" dir="2700000" algn="tl" rotWithShape="0">
+              <a:schemeClr val="bg1">
+                <a:alpha val="0"/>
+              </a:schemeClr>
+            </a:outerShdw>
+            <a:reflection blurRad="6350" stA="0" endPos="35000" dir="5400000" sy="-100000" algn="bl" rotWithShape="0"/>
+          </a:effectLst>
+        </p:spPr>
+        <p:style>
+          <a:lnRef idx="1">
+            <a:schemeClr val="accent1"/>
+          </a:lnRef>
+          <a:fillRef idx="0">
+            <a:schemeClr val="accent1"/>
+          </a:fillRef>
+          <a:effectRef idx="0">
+            <a:schemeClr val="accent1"/>
+          </a:effectRef>
+          <a:fontRef idx="minor">
+            <a:schemeClr val="tx1"/>
+          </a:fontRef>
+        </p:style>
+      </p:cxnSp>
+      <p:cxnSp>
+        <p:nvCxnSpPr>
+          <p:cNvPr id="18" name="Straight Arrow Connector 17"/>
+          <p:cNvCxnSpPr>
+            <a:endCxn id="14" idx="2"/>
+          </p:cNvCxnSpPr>
+          <p:nvPr/>
+        </p:nvCxnSpPr>
+        <p:spPr>
+          <a:xfrm flipH="1" flipV="1">
+            <a:off x="5163304" y="3041971"/>
+            <a:ext cx="9463" cy="317230"/>
+          </a:xfrm>
+          <a:prstGeom prst="straightConnector1">
+            <a:avLst/>
+          </a:prstGeom>
+          <a:ln w="12700">
+            <a:solidFill>
+              <a:srgbClr val="FF0000"/>
+            </a:solidFill>
+            <a:tailEnd type="triangle"/>
+          </a:ln>
+          <a:effectLst>
+            <a:glow rad="25400">
+              <a:schemeClr val="bg1"/>
+            </a:glow>
+            <a:outerShdw blurRad="50800" dist="38100" dir="2700000" algn="tl" rotWithShape="0">
+              <a:schemeClr val="bg1">
+                <a:alpha val="0"/>
+              </a:schemeClr>
+            </a:outerShdw>
+            <a:reflection blurRad="6350" stA="0" endPos="35000" dir="5400000" sy="-100000" algn="bl" rotWithShape="0"/>
+          </a:effectLst>
+        </p:spPr>
+        <p:style>
+          <a:lnRef idx="1">
+            <a:schemeClr val="accent1"/>
+          </a:lnRef>
+          <a:fillRef idx="0">
+            <a:schemeClr val="accent1"/>
+          </a:fillRef>
+          <a:effectRef idx="0">
+            <a:schemeClr val="accent1"/>
+          </a:effectRef>
+          <a:fontRef idx="minor">
+            <a:schemeClr val="tx1"/>
+          </a:fontRef>
+        </p:style>
+      </p:cxnSp>
+      <p:sp>
+        <p:nvSpPr>
+          <p:cNvPr id="24" name="Rectangle 23"/>
+          <p:cNvSpPr/>
+          <p:nvPr/>
+        </p:nvSpPr>
+        <p:spPr>
+          <a:xfrm>
+            <a:off x="3409136" y="1917700"/>
+            <a:ext cx="741523" cy="400050"/>
+          </a:xfrm>
+          <a:prstGeom prst="rect">
+            <a:avLst/>
+          </a:prstGeom>
+          <a:solidFill>
+            <a:schemeClr val="bg1"/>
+          </a:solidFill>
+          <a:ln>
+            <a:solidFill>
+              <a:srgbClr val="FF0000"/>
+            </a:solidFill>
+          </a:ln>
+          <a:effectLst>
+            <a:glow rad="25400">
+              <a:schemeClr val="bg1">
+                <a:alpha val="40000"/>
+              </a:schemeClr>
+            </a:glow>
+          </a:effectLst>
+        </p:spPr>
+        <p:style>
+          <a:lnRef idx="2">
+            <a:schemeClr val="accent1">
+              <a:shade val="50000"/>
+            </a:schemeClr>
+          </a:lnRef>
+          <a:fillRef idx="1">
+            <a:schemeClr val="accent1"/>
+          </a:fillRef>
+          <a:effectRef idx="0">
+            <a:schemeClr val="accent1"/>
+          </a:effectRef>
+          <a:fontRef idx="minor">
+            <a:schemeClr val="lt1"/>
+          </a:fontRef>
+        </p:style>
+        <p:txBody>
+          <a:bodyPr rtlCol="0" anchor="ctr"/>
+          <a:lstStyle/>
+          <a:p>
+            <a:pPr algn="ctr"/>
+            <a:r>
+              <a:rPr lang="sv-SE" sz="1200" b="1" dirty="0" smtClean="0">
+                <a:solidFill>
+                  <a:schemeClr val="tx1"/>
+                </a:solidFill>
+                <a:latin typeface="Times New Roman" panose="02020603050405020304" pitchFamily="18" charset="0"/>
+                <a:cs typeface="Times New Roman" panose="02020603050405020304" pitchFamily="18" charset="0"/>
+              </a:rPr>
+              <a:t>2L-3Ph </a:t>
+            </a:r>
+            <a:r>
+              <a:rPr lang="sv-SE" sz="1200" b="1" dirty="0" err="1" smtClean="0">
+                <a:solidFill>
+                  <a:schemeClr val="tx1"/>
+                </a:solidFill>
+                <a:latin typeface="Times New Roman" panose="02020603050405020304" pitchFamily="18" charset="0"/>
+                <a:cs typeface="Times New Roman" panose="02020603050405020304" pitchFamily="18" charset="0"/>
+              </a:rPr>
+              <a:t>Inverter</a:t>
+            </a:r>
+            <a:endParaRPr lang="sv-SE" sz="1200" b="1" dirty="0">
+              <a:solidFill>
+                <a:schemeClr val="tx1"/>
+              </a:solidFill>
+              <a:latin typeface="Times New Roman" panose="02020603050405020304" pitchFamily="18" charset="0"/>
+              <a:cs typeface="Times New Roman" panose="02020603050405020304" pitchFamily="18" charset="0"/>
+            </a:endParaRPr>
+          </a:p>
+        </p:txBody>
+      </p:sp>
+      <p:cxnSp>
+        <p:nvCxnSpPr>
+          <p:cNvPr id="26" name="Straight Arrow Connector 25"/>
+          <p:cNvCxnSpPr/>
+          <p:nvPr/>
+        </p:nvCxnSpPr>
+        <p:spPr>
+          <a:xfrm flipH="1" flipV="1">
+            <a:off x="5307929" y="3029457"/>
+            <a:ext cx="24768" cy="368114"/>
+          </a:xfrm>
+          <a:prstGeom prst="straightConnector1">
+            <a:avLst/>
+          </a:prstGeom>
+          <a:ln w="12700">
+            <a:solidFill>
+              <a:srgbClr val="FF0000"/>
+            </a:solidFill>
+            <a:tailEnd type="triangle"/>
+          </a:ln>
+          <a:effectLst>
+            <a:glow rad="25400">
+              <a:schemeClr val="bg1"/>
+            </a:glow>
+            <a:outerShdw blurRad="50800" dist="38100" dir="2700000" algn="tl" rotWithShape="0">
+              <a:schemeClr val="bg1">
+                <a:alpha val="0"/>
+              </a:schemeClr>
+            </a:outerShdw>
+            <a:reflection blurRad="6350" stA="0" endPos="35000" dir="5400000" sy="-100000" algn="bl" rotWithShape="0"/>
+          </a:effectLst>
+        </p:spPr>
+        <p:style>
+          <a:lnRef idx="1">
+            <a:schemeClr val="accent1"/>
+          </a:lnRef>
+          <a:fillRef idx="0">
+            <a:schemeClr val="accent1"/>
+          </a:fillRef>
+          <a:effectRef idx="0">
+            <a:schemeClr val="accent1"/>
+          </a:effectRef>
+          <a:fontRef idx="minor">
+            <a:schemeClr val="tx1"/>
+          </a:fontRef>
+        </p:style>
+      </p:cxnSp>
+      <p:cxnSp>
+        <p:nvCxnSpPr>
+          <p:cNvPr id="28" name="Straight Arrow Connector 27"/>
+          <p:cNvCxnSpPr/>
+          <p:nvPr/>
+        </p:nvCxnSpPr>
+        <p:spPr>
+          <a:xfrm flipH="1" flipV="1">
+            <a:off x="4979908" y="3029457"/>
+            <a:ext cx="12700" cy="317230"/>
+          </a:xfrm>
+          <a:prstGeom prst="straightConnector1">
+            <a:avLst/>
+          </a:prstGeom>
+          <a:ln w="12700">
+            <a:solidFill>
+              <a:srgbClr val="FF0000"/>
+            </a:solidFill>
+            <a:tailEnd type="triangle"/>
+          </a:ln>
+          <a:effectLst>
+            <a:glow rad="25400">
+              <a:schemeClr val="bg1"/>
+            </a:glow>
+            <a:outerShdw blurRad="50800" dist="38100" dir="2700000" algn="tl" rotWithShape="0">
+              <a:schemeClr val="bg1">
+                <a:alpha val="0"/>
+              </a:schemeClr>
+            </a:outerShdw>
+            <a:reflection blurRad="6350" stA="0" endPos="35000" dir="5400000" sy="-100000" algn="bl" rotWithShape="0"/>
+          </a:effectLst>
+        </p:spPr>
+        <p:style>
+          <a:lnRef idx="1">
+            <a:schemeClr val="accent1"/>
+          </a:lnRef>
+          <a:fillRef idx="0">
+            <a:schemeClr val="accent1"/>
+          </a:fillRef>
+          <a:effectRef idx="0">
+            <a:schemeClr val="accent1"/>
+          </a:effectRef>
+          <a:fontRef idx="minor">
+            <a:schemeClr val="tx1"/>
+          </a:fontRef>
+        </p:style>
+      </p:cxnSp>
+      <p:sp>
+        <p:nvSpPr>
+          <p:cNvPr id="41" name="Rectangle 40"/>
+          <p:cNvSpPr/>
+          <p:nvPr/>
+        </p:nvSpPr>
+        <p:spPr>
+          <a:xfrm>
+            <a:off x="6293684" y="1884548"/>
+            <a:ext cx="1015166" cy="244312"/>
+          </a:xfrm>
+          <a:prstGeom prst="rect">
+            <a:avLst/>
+          </a:prstGeom>
+          <a:solidFill>
+            <a:schemeClr val="bg1"/>
+          </a:solidFill>
+          <a:ln>
+            <a:solidFill>
+              <a:srgbClr val="FF0000"/>
+            </a:solidFill>
+          </a:ln>
+          <a:effectLst>
+            <a:glow rad="25400">
+              <a:schemeClr val="bg1">
+                <a:alpha val="40000"/>
+              </a:schemeClr>
+            </a:glow>
+          </a:effectLst>
+        </p:spPr>
+        <p:style>
+          <a:lnRef idx="2">
+            <a:schemeClr val="accent1">
+              <a:shade val="50000"/>
+            </a:schemeClr>
+          </a:lnRef>
+          <a:fillRef idx="1">
+            <a:schemeClr val="accent1"/>
+          </a:fillRef>
+          <a:effectRef idx="0">
+            <a:schemeClr val="accent1"/>
+          </a:effectRef>
+          <a:fontRef idx="minor">
+            <a:schemeClr val="lt1"/>
+          </a:fontRef>
+        </p:style>
+        <p:txBody>
+          <a:bodyPr rtlCol="0" anchor="ctr"/>
+          <a:lstStyle/>
+          <a:p>
+            <a:pPr algn="ctr"/>
+            <a:r>
+              <a:rPr lang="sv-SE" sz="1200" b="1" dirty="0" err="1" smtClean="0">
+                <a:solidFill>
+                  <a:schemeClr val="tx1"/>
+                </a:solidFill>
+                <a:latin typeface="Times New Roman" panose="02020603050405020304" pitchFamily="18" charset="0"/>
+                <a:cs typeface="Times New Roman" panose="02020603050405020304" pitchFamily="18" charset="0"/>
+              </a:rPr>
+              <a:t>Oscilloscope</a:t>
+            </a:r>
+            <a:endParaRPr lang="sv-SE" sz="1200" b="1" dirty="0">
+              <a:solidFill>
+                <a:schemeClr val="tx1"/>
+              </a:solidFill>
+              <a:latin typeface="Times New Roman" panose="02020603050405020304" pitchFamily="18" charset="0"/>
+              <a:cs typeface="Times New Roman" panose="02020603050405020304" pitchFamily="18" charset="0"/>
+            </a:endParaRPr>
+          </a:p>
+        </p:txBody>
+      </p:sp>
+      <p:cxnSp>
+        <p:nvCxnSpPr>
+          <p:cNvPr id="42" name="Straight Arrow Connector 41"/>
+          <p:cNvCxnSpPr/>
+          <p:nvPr/>
+        </p:nvCxnSpPr>
+        <p:spPr>
+          <a:xfrm>
+            <a:off x="5962650" y="2028825"/>
+            <a:ext cx="331034" cy="0"/>
+          </a:xfrm>
+          <a:prstGeom prst="straightConnector1">
+            <a:avLst/>
+          </a:prstGeom>
+          <a:ln w="12700">
+            <a:solidFill>
+              <a:srgbClr val="FF0000"/>
+            </a:solidFill>
+            <a:tailEnd type="triangle"/>
+          </a:ln>
+          <a:effectLst>
+            <a:glow rad="25400">
+              <a:schemeClr val="bg1"/>
+            </a:glow>
+            <a:outerShdw blurRad="50800" dist="38100" dir="2700000" algn="tl" rotWithShape="0">
+              <a:schemeClr val="bg1">
+                <a:alpha val="0"/>
+              </a:schemeClr>
+            </a:outerShdw>
+            <a:reflection blurRad="6350" stA="0" endPos="35000" dir="5400000" sy="-100000" algn="bl" rotWithShape="0"/>
+          </a:effectLst>
+        </p:spPr>
+        <p:style>
+          <a:lnRef idx="1">
+            <a:schemeClr val="accent1"/>
+          </a:lnRef>
+          <a:fillRef idx="0">
+            <a:schemeClr val="accent1"/>
+          </a:fillRef>
+          <a:effectRef idx="0">
+            <a:schemeClr val="accent1"/>
+          </a:effectRef>
+          <a:fontRef idx="minor">
+            <a:schemeClr val="tx1"/>
+          </a:fontRef>
+        </p:style>
+      </p:cxnSp>
+      <p:cxnSp>
+        <p:nvCxnSpPr>
+          <p:cNvPr id="46" name="Straight Arrow Connector 45"/>
+          <p:cNvCxnSpPr/>
+          <p:nvPr/>
+        </p:nvCxnSpPr>
+        <p:spPr>
+          <a:xfrm flipH="1" flipV="1">
+            <a:off x="6026983" y="3492500"/>
+            <a:ext cx="5517" cy="251147"/>
+          </a:xfrm>
+          <a:prstGeom prst="straightConnector1">
+            <a:avLst/>
+          </a:prstGeom>
+          <a:ln w="12700">
+            <a:solidFill>
+              <a:srgbClr val="FF0000"/>
+            </a:solidFill>
+            <a:tailEnd type="triangle"/>
+          </a:ln>
+          <a:effectLst>
+            <a:glow rad="25400">
+              <a:schemeClr val="bg1"/>
+            </a:glow>
+            <a:outerShdw blurRad="50800" dist="38100" dir="2700000" algn="tl" rotWithShape="0">
+              <a:schemeClr val="bg1">
+                <a:alpha val="0"/>
+              </a:schemeClr>
+            </a:outerShdw>
+            <a:reflection blurRad="6350" stA="0" endPos="35000" dir="5400000" sy="-100000" algn="bl" rotWithShape="0"/>
+          </a:effectLst>
+        </p:spPr>
+        <p:style>
+          <a:lnRef idx="1">
+            <a:schemeClr val="accent1"/>
+          </a:lnRef>
+          <a:fillRef idx="0">
+            <a:schemeClr val="accent1"/>
+          </a:fillRef>
+          <a:effectRef idx="0">
+            <a:schemeClr val="accent1"/>
+          </a:effectRef>
+          <a:fontRef idx="minor">
+            <a:schemeClr val="tx1"/>
+          </a:fontRef>
+        </p:style>
+      </p:cxnSp>
+      <p:sp>
+        <p:nvSpPr>
+          <p:cNvPr id="49" name="Rectangle 48"/>
+          <p:cNvSpPr/>
+          <p:nvPr/>
+        </p:nvSpPr>
+        <p:spPr>
+          <a:xfrm>
+            <a:off x="5549979" y="3244850"/>
+            <a:ext cx="954007" cy="222249"/>
+          </a:xfrm>
+          <a:prstGeom prst="rect">
+            <a:avLst/>
+          </a:prstGeom>
+          <a:solidFill>
+            <a:schemeClr val="bg1"/>
+          </a:solidFill>
+          <a:ln>
+            <a:solidFill>
+              <a:srgbClr val="FF0000"/>
+            </a:solidFill>
+          </a:ln>
+          <a:effectLst>
+            <a:glow rad="25400">
+              <a:schemeClr val="bg1">
+                <a:alpha val="40000"/>
+              </a:schemeClr>
+            </a:glow>
+          </a:effectLst>
+        </p:spPr>
+        <p:style>
+          <a:lnRef idx="2">
+            <a:schemeClr val="accent1">
+              <a:shade val="50000"/>
+            </a:schemeClr>
+          </a:lnRef>
+          <a:fillRef idx="1">
+            <a:schemeClr val="accent1"/>
+          </a:fillRef>
+          <a:effectRef idx="0">
+            <a:schemeClr val="accent1"/>
+          </a:effectRef>
+          <a:fontRef idx="minor">
+            <a:schemeClr val="lt1"/>
+          </a:fontRef>
+        </p:style>
+        <p:txBody>
+          <a:bodyPr rtlCol="0" anchor="ctr"/>
+          <a:lstStyle/>
+          <a:p>
+            <a:pPr algn="ctr"/>
+            <a:r>
+              <a:rPr lang="sv-SE" sz="1200" b="1" dirty="0" smtClean="0">
+                <a:solidFill>
+                  <a:schemeClr val="tx1"/>
+                </a:solidFill>
+                <a:latin typeface="Times New Roman" panose="02020603050405020304" pitchFamily="18" charset="0"/>
+                <a:cs typeface="Times New Roman" panose="02020603050405020304" pitchFamily="18" charset="0"/>
+              </a:rPr>
+              <a:t>Controller</a:t>
+            </a:r>
+            <a:endParaRPr lang="sv-SE" sz="1200" b="1" dirty="0">
+              <a:solidFill>
+                <a:schemeClr val="tx1"/>
+              </a:solidFill>
+              <a:latin typeface="Times New Roman" panose="02020603050405020304" pitchFamily="18" charset="0"/>
+              <a:cs typeface="Times New Roman" panose="02020603050405020304" pitchFamily="18" charset="0"/>
+            </a:endParaRPr>
+          </a:p>
+        </p:txBody>
+      </p:sp>
+      <p:sp>
+        <p:nvSpPr>
+          <p:cNvPr id="54" name="Rectangle 53"/>
+          <p:cNvSpPr/>
+          <p:nvPr/>
+        </p:nvSpPr>
+        <p:spPr>
+          <a:xfrm>
+            <a:off x="2449909" y="1911350"/>
+            <a:ext cx="741523" cy="400050"/>
+          </a:xfrm>
+          <a:prstGeom prst="rect">
+            <a:avLst/>
+          </a:prstGeom>
+          <a:solidFill>
+            <a:schemeClr val="bg1"/>
+          </a:solidFill>
+          <a:ln>
+            <a:solidFill>
+              <a:srgbClr val="FF0000"/>
+            </a:solidFill>
+          </a:ln>
+          <a:effectLst>
+            <a:glow rad="25400">
+              <a:schemeClr val="bg1">
+                <a:alpha val="40000"/>
+              </a:schemeClr>
+            </a:glow>
+          </a:effectLst>
+        </p:spPr>
+        <p:style>
+          <a:lnRef idx="2">
+            <a:schemeClr val="accent1">
+              <a:shade val="50000"/>
+            </a:schemeClr>
+          </a:lnRef>
+          <a:fillRef idx="1">
+            <a:schemeClr val="accent1"/>
+          </a:fillRef>
+          <a:effectRef idx="0">
+            <a:schemeClr val="accent1"/>
+          </a:effectRef>
+          <a:fontRef idx="minor">
+            <a:schemeClr val="lt1"/>
+          </a:fontRef>
+        </p:style>
+        <p:txBody>
+          <a:bodyPr rtlCol="0" anchor="ctr"/>
+          <a:lstStyle/>
+          <a:p>
+            <a:pPr algn="ctr"/>
+            <a:r>
+              <a:rPr lang="sv-SE" sz="1200" b="1" dirty="0" smtClean="0">
+                <a:solidFill>
+                  <a:schemeClr val="tx1"/>
+                </a:solidFill>
+                <a:latin typeface="Times New Roman" panose="02020603050405020304" pitchFamily="18" charset="0"/>
+                <a:cs typeface="Times New Roman" panose="02020603050405020304" pitchFamily="18" charset="0"/>
+              </a:rPr>
+              <a:t>Power </a:t>
+            </a:r>
+            <a:r>
+              <a:rPr lang="sv-SE" sz="1200" b="1" dirty="0" err="1" smtClean="0">
+                <a:solidFill>
+                  <a:schemeClr val="tx1"/>
+                </a:solidFill>
+                <a:latin typeface="Times New Roman" panose="02020603050405020304" pitchFamily="18" charset="0"/>
+                <a:cs typeface="Times New Roman" panose="02020603050405020304" pitchFamily="18" charset="0"/>
+              </a:rPr>
+              <a:t>Supply</a:t>
+            </a:r>
+            <a:endParaRPr lang="sv-SE" sz="1200" b="1" dirty="0">
+              <a:solidFill>
+                <a:schemeClr val="tx1"/>
+              </a:solidFill>
+              <a:latin typeface="Times New Roman" panose="02020603050405020304" pitchFamily="18" charset="0"/>
+              <a:cs typeface="Times New Roman" panose="02020603050405020304" pitchFamily="18" charset="0"/>
+            </a:endParaRPr>
+          </a:p>
+        </p:txBody>
+      </p:sp>
+      <p:cxnSp>
+        <p:nvCxnSpPr>
+          <p:cNvPr id="55" name="Straight Arrow Connector 54"/>
+          <p:cNvCxnSpPr/>
+          <p:nvPr/>
+        </p:nvCxnSpPr>
+        <p:spPr>
+          <a:xfrm flipH="1" flipV="1">
+            <a:off x="7665283" y="2903883"/>
+            <a:ext cx="5517" cy="251147"/>
+          </a:xfrm>
+          <a:prstGeom prst="straightConnector1">
+            <a:avLst/>
+          </a:prstGeom>
+          <a:ln w="12700">
+            <a:solidFill>
+              <a:srgbClr val="FF0000"/>
+            </a:solidFill>
+            <a:tailEnd type="triangle"/>
+          </a:ln>
+          <a:effectLst>
+            <a:glow rad="25400">
+              <a:schemeClr val="bg1"/>
+            </a:glow>
+            <a:outerShdw blurRad="50800" dist="38100" dir="2700000" algn="tl" rotWithShape="0">
+              <a:schemeClr val="bg1">
+                <a:alpha val="0"/>
+              </a:schemeClr>
+            </a:outerShdw>
+            <a:reflection blurRad="6350" stA="0" endPos="35000" dir="5400000" sy="-100000" algn="bl" rotWithShape="0"/>
+          </a:effectLst>
+        </p:spPr>
+        <p:style>
+          <a:lnRef idx="1">
+            <a:schemeClr val="accent1"/>
+          </a:lnRef>
+          <a:fillRef idx="0">
+            <a:schemeClr val="accent1"/>
+          </a:fillRef>
+          <a:effectRef idx="0">
+            <a:schemeClr val="accent1"/>
+          </a:effectRef>
+          <a:fontRef idx="minor">
+            <a:schemeClr val="tx1"/>
+          </a:fontRef>
+        </p:style>
+      </p:cxnSp>
+      <p:sp>
+        <p:nvSpPr>
+          <p:cNvPr id="56" name="Rectangle 55"/>
+          <p:cNvSpPr/>
+          <p:nvPr/>
+        </p:nvSpPr>
+        <p:spPr>
+          <a:xfrm>
+            <a:off x="7455733" y="2684921"/>
+            <a:ext cx="419100" cy="217511"/>
+          </a:xfrm>
+          <a:prstGeom prst="rect">
+            <a:avLst/>
+          </a:prstGeom>
+          <a:solidFill>
+            <a:schemeClr val="bg1"/>
+          </a:solidFill>
+          <a:ln>
+            <a:solidFill>
+              <a:srgbClr val="FF0000"/>
+            </a:solidFill>
+          </a:ln>
+          <a:effectLst>
+            <a:glow rad="25400">
+              <a:schemeClr val="bg1">
+                <a:alpha val="40000"/>
+              </a:schemeClr>
+            </a:glow>
+          </a:effectLst>
+        </p:spPr>
+        <p:style>
+          <a:lnRef idx="2">
+            <a:schemeClr val="accent1">
+              <a:shade val="50000"/>
+            </a:schemeClr>
+          </a:lnRef>
+          <a:fillRef idx="1">
+            <a:schemeClr val="accent1"/>
+          </a:fillRef>
+          <a:effectRef idx="0">
+            <a:schemeClr val="accent1"/>
+          </a:effectRef>
+          <a:fontRef idx="minor">
+            <a:schemeClr val="lt1"/>
+          </a:fontRef>
+        </p:style>
+        <p:txBody>
+          <a:bodyPr rtlCol="0" anchor="ctr"/>
+          <a:lstStyle/>
+          <a:p>
+            <a:pPr algn="ctr"/>
+            <a:r>
+              <a:rPr lang="sv-SE" sz="1200" b="1" dirty="0" smtClean="0">
+                <a:solidFill>
+                  <a:schemeClr val="tx1"/>
+                </a:solidFill>
+                <a:latin typeface="Times New Roman" panose="02020603050405020304" pitchFamily="18" charset="0"/>
+                <a:cs typeface="Times New Roman" panose="02020603050405020304" pitchFamily="18" charset="0"/>
+              </a:rPr>
+              <a:t>PC</a:t>
+            </a:r>
+            <a:endParaRPr lang="sv-SE" sz="1200" b="1" dirty="0">
+              <a:solidFill>
+                <a:schemeClr val="tx1"/>
+              </a:solidFill>
+              <a:latin typeface="Times New Roman" panose="02020603050405020304" pitchFamily="18" charset="0"/>
+              <a:cs typeface="Times New Roman" panose="02020603050405020304" pitchFamily="18" charset="0"/>
+            </a:endParaRPr>
+          </a:p>
+        </p:txBody>
+      </p:sp>
+    </p:spTree>
+    <p:extLst>
+      <p:ext uri="{BB962C8B-B14F-4D97-AF65-F5344CB8AC3E}">
+        <p14:creationId xmlns:p14="http://schemas.microsoft.com/office/powerpoint/2010/main" val="3995131930"/>
+      </p:ext>
+    </p:extLst>
+  </p:cSld>
+  <p:clrMapOvr>
+    <a:masterClrMapping/>
+  </p:clrMapOvr>
+</p:sld>
+</file>
+
+<file path=ppt/slides/slide3.xml><?xml version="1.0" encoding="utf-8"?>
+<p:sld xmlns:a="http://schemas.openxmlformats.org/drawingml/2006/main" xmlns:r="http://schemas.openxmlformats.org/officeDocument/2006/relationships" xmlns:p="http://schemas.openxmlformats.org/presentationml/2006/main">
+  <p:cSld>
+    <p:spTree>
+      <p:nvGrpSpPr>
+        <p:cNvPr id="1" name=""/>
+        <p:cNvGrpSpPr/>
+        <p:nvPr/>
+      </p:nvGrpSpPr>
+      <p:grpSpPr>
+        <a:xfrm>
+          <a:off x="0" y="0"/>
+          <a:ext cx="0" cy="0"/>
+          <a:chOff x="0" y="0"/>
+          <a:chExt cx="0" cy="0"/>
+        </a:xfrm>
+      </p:grpSpPr>
+      <p:pic>
+        <p:nvPicPr>
+          <p:cNvPr id="4" name="Picture 3"/>
+          <p:cNvPicPr>
+            <a:picLocks noChangeAspect="1"/>
+          </p:cNvPicPr>
+          <p:nvPr/>
+        </p:nvPicPr>
+        <p:blipFill rotWithShape="1">
+          <a:blip r:embed="rId2" cstate="print">
+            <a:extLst>
+              <a:ext uri="{28A0092B-C50C-407E-A947-70E740481C1C}">
+                <a14:useLocalDpi xmlns:a14="http://schemas.microsoft.com/office/drawing/2010/main" val="0"/>
+              </a:ext>
+            </a:extLst>
+          </a:blip>
           <a:srcRect b="12583"/>
           <a:stretch/>
         </p:blipFill>
@@ -3093,8 +3999,8 @@
         </p:blipFill>
         <p:spPr>
           <a:xfrm>
-            <a:off x="2800829" y="1162351"/>
-            <a:ext cx="1222531" cy="984684"/>
+            <a:off x="2965384" y="1393825"/>
+            <a:ext cx="936721" cy="754479"/>
           </a:xfrm>
           <a:prstGeom prst="rect">
             <a:avLst/>
@@ -3117,8 +4023,8 @@
         </p:blipFill>
         <p:spPr>
           <a:xfrm>
-            <a:off x="3281480" y="655546"/>
-            <a:ext cx="1351479" cy="1013610"/>
+            <a:off x="2965384" y="739775"/>
+            <a:ext cx="965199" cy="723900"/>
           </a:xfrm>
           <a:prstGeom prst="rect">
             <a:avLst/>

</xml_diff>